<commit_message>
Use references from v1
</commit_message>
<xml_diff>
--- a/report-generator/tests/report_generator/integration/references/reference_modernization.pptx
+++ b/report-generator/tests/report_generator/integration/references/reference_modernization.pptx
@@ -317,22 +317,22 @@
                   <c:v>138.76191</c:v>
                 </c:pt>
                 <c:pt idx="1">
-                  <c:v>34.85719</c:v>
+                  <c:v>34.857190000000003</c:v>
                 </c:pt>
                 <c:pt idx="2">
-                  <c:v>24.57473</c:v>
+                  <c:v>24.574729999999999</c:v>
                 </c:pt>
                 <c:pt idx="3">
                   <c:v>18.88447</c:v>
                 </c:pt>
                 <c:pt idx="4">
-                  <c:v>18.38069</c:v>
+                  <c:v>18.380690000000001</c:v>
                 </c:pt>
                 <c:pt idx="5">
                   <c:v>18.16938</c:v>
                 </c:pt>
                 <c:pt idx="6">
-                  <c:v>12.48652</c:v>
+                  <c:v>12.486520000000001</c:v>
                 </c:pt>
                 <c:pt idx="7">
                   <c:v>3.17265</c:v>
@@ -344,10 +344,10 @@
                   <c:v>1.53173</c:v>
                 </c:pt>
                 <c:pt idx="10">
-                  <c:v>1.04072</c:v>
+                  <c:v>1.0407200000000001</c:v>
                 </c:pt>
                 <c:pt idx="11">
-                  <c:v>0.52362</c:v>
+                  <c:v>0.52361999999999997</c:v>
                 </c:pt>
               </c:numCache>
             </c:numRef>
@@ -442,7 +442,7 @@
                   <c:v>12.391236676501368</c:v>
                 </c:pt>
                 <c:pt idx="3">
-                  <c:v>58.74034676610504</c:v>
+                  <c:v>58.740346766105041</c:v>
                 </c:pt>
                 <c:pt idx="4">
                   <c:v>17.402782706155662</c:v>
@@ -454,10 +454,10 @@
                   <c:v>14.749963870967802</c:v>
                 </c:pt>
                 <c:pt idx="7">
-                  <c:v>9.819366324817128</c:v>
+                  <c:v>9.8193663248171283</c:v>
                 </c:pt>
                 <c:pt idx="8">
-                  <c:v>8.332723851055352</c:v>
+                  <c:v>8.3327238510553521</c:v>
                 </c:pt>
                 <c:pt idx="9">
                   <c:v>5.2096993699186935</c:v>
@@ -663,7 +663,7 @@
               <c:strCache>
                 <c:ptCount val="1"/>
                 <c:pt idx="0">
-                  <c:v>Critical</c:v>
+                  <c:v>Estimated change speed increase</c:v>
                 </c:pt>
               </c:strCache>
             </c:strRef>
@@ -680,775 +680,54 @@
           <c:invertIfNegative val="0"/>
           <c:xVal>
             <c:numRef>
-              <c:f>Sheet1!$A$2:$A$1</c:f>
+              <c:f>Sheet1!$A$2:$A$4</c:f>
               <c:numCache>
                 <c:formatCode>General</c:formatCode>
-                <c:ptCount val="0"/>
-              </c:numCache>
-            </c:numRef>
-          </c:xVal>
-          <c:yVal>
-            <c:numRef>
-              <c:f>Sheet1!$B$2:$B$1</c:f>
-              <c:numCache>
-                <c:formatCode>General</c:formatCode>
-                <c:ptCount val="0"/>
-              </c:numCache>
-            </c:numRef>
-          </c:yVal>
-          <c:bubbleSize>
-            <c:numRef>
-              <c:f>Sheet1!$C$2:$C$1</c:f>
-              <c:numCache>
-                <c:formatCode>General</c:formatCode>
-                <c:ptCount val="0"/>
-              </c:numCache>
-            </c:numRef>
-          </c:bubbleSize>
-          <c:bubble3D val="0"/>
-          <c:extLst>
-            <c:ext xmlns:c16="http://schemas.microsoft.com/office/drawing/2014/chart" uri="{C3380CC4-5D6E-409C-BE32-E72D297353CC}">
-              <c16:uniqueId val="{00000000-D4B8-B94C-91E4-2DDF998DBB50}"/>
-            </c:ext>
-          </c:extLst>
-        </c:ser>
-        <c:ser>
-          <c:idx val="1"/>
-          <c:order val="1"/>
-          <c:tx>
-            <c:strRef>
-              <c:f>Sheet1!$B$3</c:f>
-              <c:strCache>
-                <c:ptCount val="1"/>
+                <c:ptCount val="3"/>
                 <c:pt idx="0">
-                  <c:v>High</c:v>
-                </c:pt>
-              </c:strCache>
-            </c:strRef>
-          </c:tx>
-          <c:spPr>
-            <a:solidFill>
-              <a:schemeClr val="accent1"/>
-            </a:solidFill>
-            <a:ln w="19050">
-              <a:noFill/>
-            </a:ln>
-            <a:effectLst/>
-          </c:spPr>
-          <c:invertIfNegative val="0"/>
-          <c:xVal>
-            <c:numRef>
-              <c:f>Sheet1!$A$4:$A$3</c:f>
-              <c:numCache>
-                <c:formatCode>General</c:formatCode>
-                <c:ptCount val="0"/>
-              </c:numCache>
-            </c:numRef>
-          </c:xVal>
-          <c:yVal>
-            <c:numRef>
-              <c:f>Sheet1!$B$4:$B$3</c:f>
-              <c:numCache>
-                <c:formatCode>General</c:formatCode>
-                <c:ptCount val="0"/>
-              </c:numCache>
-            </c:numRef>
-          </c:yVal>
-          <c:bubbleSize>
-            <c:numRef>
-              <c:f>Sheet1!$C$4:$C$3</c:f>
-              <c:numCache>
-                <c:formatCode>General</c:formatCode>
-                <c:ptCount val="0"/>
-              </c:numCache>
-            </c:numRef>
-          </c:bubbleSize>
-          <c:bubble3D val="0"/>
-          <c:extLst>
-            <c:ext xmlns:c16="http://schemas.microsoft.com/office/drawing/2014/chart" uri="{C3380CC4-5D6E-409C-BE32-E72D297353CC}">
-              <c16:uniqueId val="{00000000-D4B8-B94C-91E4-2DDF998DBB50}"/>
-            </c:ext>
-          </c:extLst>
-        </c:ser>
-        <c:ser>
-          <c:idx val="2"/>
-          <c:order val="2"/>
-          <c:tx>
-            <c:strRef>
-              <c:f>Sheet1!$B$5</c:f>
-              <c:strCache>
-                <c:ptCount val="1"/>
-                <c:pt idx="0">
-                  <c:v>Medium</c:v>
-                </c:pt>
-              </c:strCache>
-            </c:strRef>
-          </c:tx>
-          <c:spPr>
-            <a:solidFill>
-              <a:schemeClr val="accent1"/>
-            </a:solidFill>
-            <a:ln w="19050">
-              <a:noFill/>
-            </a:ln>
-            <a:effectLst/>
-          </c:spPr>
-          <c:invertIfNegative val="0"/>
-          <c:xVal>
-            <c:numRef>
-              <c:f>Sheet1!$A$6:$A$5</c:f>
-              <c:numCache>
-                <c:formatCode>General</c:formatCode>
-                <c:ptCount val="0"/>
-              </c:numCache>
-            </c:numRef>
-          </c:xVal>
-          <c:yVal>
-            <c:numRef>
-              <c:f>Sheet1!$B$6:$B$5</c:f>
-              <c:numCache>
-                <c:formatCode>General</c:formatCode>
-                <c:ptCount val="0"/>
-              </c:numCache>
-            </c:numRef>
-          </c:yVal>
-          <c:bubbleSize>
-            <c:numRef>
-              <c:f>Sheet1!$C$6:$C$5</c:f>
-              <c:numCache>
-                <c:formatCode>General</c:formatCode>
-                <c:ptCount val="0"/>
-              </c:numCache>
-            </c:numRef>
-          </c:bubbleSize>
-          <c:bubble3D val="0"/>
-          <c:extLst>
-            <c:ext xmlns:c16="http://schemas.microsoft.com/office/drawing/2014/chart" uri="{C3380CC4-5D6E-409C-BE32-E72D297353CC}">
-              <c16:uniqueId val="{00000000-D4B8-B94C-91E4-2DDF998DBB50}"/>
-            </c:ext>
-          </c:extLst>
-        </c:ser>
-        <c:ser>
-          <c:idx val="3"/>
-          <c:order val="3"/>
-          <c:tx>
-            <c:strRef>
-              <c:f>Sheet1!$B$7</c:f>
-              <c:strCache>
-                <c:ptCount val="1"/>
-                <c:pt idx="0">
-                  <c:v>Low</c:v>
-                </c:pt>
-              </c:strCache>
-            </c:strRef>
-          </c:tx>
-          <c:spPr>
-            <a:solidFill>
-              <a:schemeClr val="accent1"/>
-            </a:solidFill>
-            <a:ln w="19050">
-              <a:noFill/>
-            </a:ln>
-            <a:effectLst/>
-          </c:spPr>
-          <c:invertIfNegative val="0"/>
-          <c:xVal>
-            <c:numRef>
-              <c:f>Sheet1!$A$8:$A$7</c:f>
-              <c:numCache>
-                <c:formatCode>General</c:formatCode>
-                <c:ptCount val="0"/>
-              </c:numCache>
-            </c:numRef>
-          </c:xVal>
-          <c:yVal>
-            <c:numRef>
-              <c:f>Sheet1!$B$8:$B$7</c:f>
-              <c:numCache>
-                <c:formatCode>General</c:formatCode>
-                <c:ptCount val="0"/>
-              </c:numCache>
-            </c:numRef>
-          </c:yVal>
-          <c:bubbleSize>
-            <c:numRef>
-              <c:f>Sheet1!$C$8:$C$7</c:f>
-              <c:numCache>
-                <c:formatCode>General</c:formatCode>
-                <c:ptCount val="0"/>
-              </c:numCache>
-            </c:numRef>
-          </c:bubbleSize>
-          <c:bubble3D val="0"/>
-          <c:extLst>
-            <c:ext xmlns:c16="http://schemas.microsoft.com/office/drawing/2014/chart" uri="{C3380CC4-5D6E-409C-BE32-E72D297353CC}">
-              <c16:uniqueId val="{00000000-D4B8-B94C-91E4-2DDF998DBB50}"/>
-            </c:ext>
-          </c:extLst>
-        </c:ser>
-        <c:ser>
-          <c:idx val="4"/>
-          <c:order val="4"/>
-          <c:tx>
-            <c:strRef>
-              <c:f>Sheet1!$B$9</c:f>
-              <c:strCache>
-                <c:ptCount val="1"/>
-                <c:pt idx="0">
-                  <c:v>Unknown</c:v>
-                </c:pt>
-              </c:strCache>
-            </c:strRef>
-          </c:tx>
-          <c:spPr>
-            <a:solidFill>
-              <a:schemeClr val="accent1"/>
-            </a:solidFill>
-            <a:ln w="19050">
-              <a:noFill/>
-            </a:ln>
-            <a:effectLst/>
-          </c:spPr>
-          <c:invertIfNegative val="0"/>
-          <c:dPt>
-            <c:idx val="0"/>
-            <c:spPr>
-              <a:solidFill>
-                <a:srgbClr val="8A98A8"/>
-              </a:solidFill>
-              <a:ln>
-                <a:solidFill>
-                  <a:srgbClr val="FFFFFF"/>
-                </a:solidFill>
-              </a:ln>
-            </c:spPr>
-          </c:dPt>
-          <c:dPt>
-            <c:idx val="1"/>
-            <c:spPr>
-              <a:solidFill>
-                <a:srgbClr val="8A98A8"/>
-              </a:solidFill>
-              <a:ln>
-                <a:solidFill>
-                  <a:srgbClr val="FFFFFF"/>
-                </a:solidFill>
-              </a:ln>
-            </c:spPr>
-          </c:dPt>
-          <c:dPt>
-            <c:idx val="2"/>
-            <c:spPr>
-              <a:solidFill>
-                <a:srgbClr val="8A98A8"/>
-              </a:solidFill>
-              <a:ln>
-                <a:solidFill>
-                  <a:srgbClr val="FFFFFF"/>
-                </a:solidFill>
-              </a:ln>
-            </c:spPr>
-          </c:dPt>
-          <c:dPt>
-            <c:idx val="3"/>
-            <c:spPr>
-              <a:solidFill>
-                <a:srgbClr val="8A98A8"/>
-              </a:solidFill>
-              <a:ln>
-                <a:solidFill>
-                  <a:srgbClr val="FFFFFF"/>
-                </a:solidFill>
-              </a:ln>
-            </c:spPr>
-          </c:dPt>
-          <c:dPt>
-            <c:idx val="4"/>
-            <c:spPr>
-              <a:solidFill>
-                <a:srgbClr val="8A98A8"/>
-              </a:solidFill>
-              <a:ln>
-                <a:solidFill>
-                  <a:srgbClr val="FFFFFF"/>
-                </a:solidFill>
-              </a:ln>
-            </c:spPr>
-          </c:dPt>
-          <c:dPt>
-            <c:idx val="5"/>
-            <c:spPr>
-              <a:solidFill>
-                <a:srgbClr val="8A98A8"/>
-              </a:solidFill>
-              <a:ln>
-                <a:solidFill>
-                  <a:srgbClr val="FFFFFF"/>
-                </a:solidFill>
-              </a:ln>
-            </c:spPr>
-          </c:dPt>
-          <c:dPt>
-            <c:idx val="6"/>
-            <c:spPr>
-              <a:solidFill>
-                <a:srgbClr val="8A98A8"/>
-              </a:solidFill>
-              <a:ln>
-                <a:solidFill>
-                  <a:srgbClr val="FFFFFF"/>
-                </a:solidFill>
-              </a:ln>
-            </c:spPr>
-          </c:dPt>
-          <c:dPt>
-            <c:idx val="7"/>
-            <c:spPr>
-              <a:solidFill>
-                <a:srgbClr val="8A98A8"/>
-              </a:solidFill>
-              <a:ln>
-                <a:solidFill>
-                  <a:srgbClr val="FFFFFF"/>
-                </a:solidFill>
-              </a:ln>
-            </c:spPr>
-          </c:dPt>
-          <c:dPt>
-            <c:idx val="8"/>
-            <c:spPr>
-              <a:solidFill>
-                <a:srgbClr val="8A98A8"/>
-              </a:solidFill>
-              <a:ln>
-                <a:solidFill>
-                  <a:srgbClr val="FFFFFF"/>
-                </a:solidFill>
-              </a:ln>
-            </c:spPr>
-          </c:dPt>
-          <c:dPt>
-            <c:idx val="9"/>
-            <c:spPr>
-              <a:solidFill>
-                <a:srgbClr val="8A98A8"/>
-              </a:solidFill>
-              <a:ln>
-                <a:solidFill>
-                  <a:srgbClr val="FFFFFF"/>
-                </a:solidFill>
-              </a:ln>
-            </c:spPr>
-          </c:dPt>
-          <c:dPt>
-            <c:idx val="10"/>
-            <c:spPr>
-              <a:solidFill>
-                <a:srgbClr val="8A98A8"/>
-              </a:solidFill>
-              <a:ln>
-                <a:solidFill>
-                  <a:srgbClr val="FFFFFF"/>
-                </a:solidFill>
-              </a:ln>
-            </c:spPr>
-          </c:dPt>
-          <c:dPt>
-            <c:idx val="11"/>
-            <c:spPr>
-              <a:solidFill>
-                <a:srgbClr val="8A98A8"/>
-              </a:solidFill>
-              <a:ln>
-                <a:solidFill>
-                  <a:srgbClr val="FFFFFF"/>
-                </a:solidFill>
-              </a:ln>
-            </c:spPr>
-          </c:dPt>
-          <c:dLbls>
-            <c:dLbl>
-              <c:idx val="0"/>
-              <c:tx>
-                <c:rich>
-                  <a:bodyPr/>
-                  <a:lstStyle/>
-                  <a:p>
-                    <a:r>
-                      <a:t>integrationtest-elasticsearch</a:t>
-                    </a:r>
-                  </a:p>
-                </c:rich>
-              </c:tx>
-              <c:showLegendKey val="0"/>
-              <c:showVal val="1"/>
-              <c:showCatName val="0"/>
-              <c:showSerName val="0"/>
-              <c:showPercent val="0"/>
-              <c:showBubbleSize val="0"/>
-            </c:dLbl>
-            <c:dLbl>
-              <c:idx val="1"/>
-              <c:tx>
-                <c:rich>
-                  <a:bodyPr/>
-                  <a:lstStyle/>
-                  <a:p>
-                    <a:r>
-                      <a:t>integrationtest-airflow</a:t>
-                    </a:r>
-                  </a:p>
-                </c:rich>
-              </c:tx>
-              <c:showLegendKey val="0"/>
-              <c:showVal val="1"/>
-              <c:showCatName val="0"/>
-              <c:showSerName val="0"/>
-              <c:showPercent val="0"/>
-              <c:showBubbleSize val="0"/>
-            </c:dLbl>
-            <c:dLbl>
-              <c:idx val="2"/>
-              <c:tx>
-                <c:rich>
-                  <a:bodyPr/>
-                  <a:lstStyle/>
-                  <a:p>
-                    <a:r>
-                      <a:t>integrationtest-vscode</a:t>
-                    </a:r>
-                  </a:p>
-                </c:rich>
-              </c:tx>
-              <c:showLegendKey val="0"/>
-              <c:showVal val="1"/>
-              <c:showCatName val="0"/>
-              <c:showSerName val="0"/>
-              <c:showPercent val="0"/>
-              <c:showBubbleSize val="0"/>
-            </c:dLbl>
-            <c:dLbl>
-              <c:idx val="3"/>
-              <c:tx>
-                <c:rich>
-                  <a:bodyPr/>
-                  <a:lstStyle/>
-                  <a:p>
-                    <a:r>
-                      <a:t>integrationtest-git</a:t>
-                    </a:r>
-                  </a:p>
-                </c:rich>
-              </c:tx>
-              <c:showLegendKey val="0"/>
-              <c:showVal val="1"/>
-              <c:showCatName val="0"/>
-              <c:showSerName val="0"/>
-              <c:showPercent val="0"/>
-              <c:showBubbleSize val="0"/>
-            </c:dLbl>
-            <c:dLbl>
-              <c:idx val="4"/>
-              <c:tx>
-                <c:rich>
-                  <a:bodyPr/>
-                  <a:lstStyle/>
-                  <a:p>
-                    <a:r>
-                      <a:t>integrationtest-kafka</a:t>
-                    </a:r>
-                  </a:p>
-                </c:rich>
-              </c:tx>
-              <c:showLegendKey val="0"/>
-              <c:showVal val="1"/>
-              <c:showCatName val="0"/>
-              <c:showSerName val="0"/>
-              <c:showPercent val="0"/>
-              <c:showBubbleSize val="0"/>
-            </c:dLbl>
-            <c:dLbl>
-              <c:idx val="5"/>
-              <c:tx>
-                <c:rich>
-                  <a:bodyPr/>
-                  <a:lstStyle/>
-                  <a:p>
-                    <a:r>
-                      <a:t>integrationtest-jruby</a:t>
-                    </a:r>
-                  </a:p>
-                </c:rich>
-              </c:tx>
-              <c:showLegendKey val="0"/>
-              <c:showVal val="1"/>
-              <c:showCatName val="0"/>
-              <c:showSerName val="0"/>
-              <c:showPercent val="0"/>
-              <c:showBubbleSize val="0"/>
-            </c:dLbl>
-            <c:dLbl>
-              <c:idx val="6"/>
-              <c:tx>
-                <c:rich>
-                  <a:bodyPr/>
-                  <a:lstStyle/>
-                  <a:p>
-                    <a:r>
-                      <a:t>integrationtest-druid</a:t>
-                    </a:r>
-                  </a:p>
-                </c:rich>
-              </c:tx>
-              <c:showLegendKey val="0"/>
-              <c:showVal val="1"/>
-              <c:showCatName val="0"/>
-              <c:showSerName val="0"/>
-              <c:showPercent val="0"/>
-              <c:showBubbleSize val="0"/>
-            </c:dLbl>
-            <c:dLbl>
-              <c:idx val="7"/>
-              <c:tx>
-                <c:rich>
-                  <a:bodyPr/>
-                  <a:lstStyle/>
-                  <a:p>
-                    <a:r>
-                      <a:t>integrationtest-webpack</a:t>
-                    </a:r>
-                  </a:p>
-                </c:rich>
-              </c:tx>
-              <c:showLegendKey val="0"/>
-              <c:showVal val="1"/>
-              <c:showCatName val="0"/>
-              <c:showSerName val="0"/>
-              <c:showPercent val="0"/>
-              <c:showBubbleSize val="0"/>
-            </c:dLbl>
-            <c:dLbl>
-              <c:idx val="8"/>
-              <c:tx>
-                <c:rich>
-                  <a:bodyPr/>
-                  <a:lstStyle/>
-                  <a:p>
-                    <a:r>
-                      <a:t>integrationtest-electron</a:t>
-                    </a:r>
-                  </a:p>
-                </c:rich>
-              </c:tx>
-              <c:showLegendKey val="0"/>
-              <c:showVal val="1"/>
-              <c:showCatName val="0"/>
-              <c:showSerName val="0"/>
-              <c:showPercent val="0"/>
-              <c:showBubbleSize val="0"/>
-            </c:dLbl>
-            <c:dLbl>
-              <c:idx val="9"/>
-              <c:tx>
-                <c:rich>
-                  <a:bodyPr/>
-                  <a:lstStyle/>
-                  <a:p>
-                    <a:r>
-                      <a:t>integrationtest-bazel</a:t>
-                    </a:r>
-                  </a:p>
-                </c:rich>
-              </c:tx>
-              <c:showLegendKey val="0"/>
-              <c:showVal val="1"/>
-              <c:showCatName val="0"/>
-              <c:showSerName val="0"/>
-              <c:showPercent val="0"/>
-              <c:showBubbleSize val="0"/>
-            </c:dLbl>
-            <c:dLbl>
-              <c:idx val="10"/>
-              <c:tx>
-                <c:rich>
-                  <a:bodyPr/>
-                  <a:lstStyle/>
-                  <a:p>
-                    <a:r>
-                      <a:t>integrationtest-facebookyoga</a:t>
-                    </a:r>
-                  </a:p>
-                </c:rich>
-              </c:tx>
-              <c:showLegendKey val="0"/>
-              <c:showVal val="1"/>
-              <c:showCatName val="0"/>
-              <c:showSerName val="0"/>
-              <c:showPercent val="0"/>
-              <c:showBubbleSize val="0"/>
-            </c:dLbl>
-            <c:dLbl>
-              <c:idx val="11"/>
-              <c:tx>
-                <c:rich>
-                  <a:bodyPr/>
-                  <a:lstStyle/>
-                  <a:p>
-                    <a:r>
-                      <a:t>integrationtest-zuul</a:t>
-                    </a:r>
-                  </a:p>
-                </c:rich>
-              </c:tx>
-              <c:showLegendKey val="0"/>
-              <c:showVal val="1"/>
-              <c:showCatName val="0"/>
-              <c:showSerName val="0"/>
-              <c:showPercent val="0"/>
-              <c:showBubbleSize val="0"/>
-            </c:dLbl>
-            <c:showLegendKey val="0"/>
-            <c:showVal val="0"/>
-            <c:showCatName val="0"/>
-            <c:showSerName val="0"/>
-            <c:showPercent val="0"/>
-            <c:showBubbleSize val="0"/>
-            <c:showLeaderLines val="1"/>
-          </c:dLbls>
-          <c:xVal>
-            <c:numRef>
-              <c:f>Sheet1!$A$10:$A$21</c:f>
-              <c:numCache>
-                <c:formatCode>General</c:formatCode>
-                <c:ptCount val="12"/>
-                <c:pt idx="0">
-                  <c:v>138.76191</c:v>
+                  <c:v>0.7</c:v>
                 </c:pt>
                 <c:pt idx="1">
-                  <c:v>34.85719</c:v>
+                  <c:v>1.8</c:v>
                 </c:pt>
                 <c:pt idx="2">
-                  <c:v>18.88447</c:v>
-                </c:pt>
-                <c:pt idx="3">
-                  <c:v>24.57473</c:v>
-                </c:pt>
-                <c:pt idx="4">
-                  <c:v>18.16938</c:v>
-                </c:pt>
-                <c:pt idx="5">
-                  <c:v>18.38069</c:v>
-                </c:pt>
-                <c:pt idx="6">
-                  <c:v>12.48652</c:v>
-                </c:pt>
-                <c:pt idx="7">
-                  <c:v>2.69231</c:v>
-                </c:pt>
-                <c:pt idx="8">
-                  <c:v>3.17265</c:v>
-                </c:pt>
-                <c:pt idx="9">
-                  <c:v>1.53173</c:v>
-                </c:pt>
-                <c:pt idx="10">
-                  <c:v>1.04072</c:v>
-                </c:pt>
-                <c:pt idx="11">
-                  <c:v>0.52362</c:v>
+                  <c:v>2.6</c:v>
                 </c:pt>
               </c:numCache>
             </c:numRef>
           </c:xVal>
           <c:yVal>
             <c:numRef>
-              <c:f>Sheet1!$B$10:$B$21</c:f>
+              <c:f>Sheet1!$B$2:$B$4</c:f>
               <c:numCache>
-                <c:formatCode>General</c:formatCode>
-                <c:ptCount val="12"/>
+                <c:formatCode>0%</c:formatCode>
+                <c:ptCount val="3"/>
                 <c:pt idx="0">
-                  <c:v>88.2573</c:v>
+                  <c:v>2.7</c:v>
                 </c:pt>
                 <c:pt idx="1">
-                  <c:v>80.33779</c:v>
+                  <c:v>3.2</c:v>
                 </c:pt>
                 <c:pt idx="2">
-                  <c:v>46.60242</c:v>
-                </c:pt>
-                <c:pt idx="3">
-                  <c:v>96.01779</c:v>
-                </c:pt>
-                <c:pt idx="4">
-                  <c:v>77.13151</c:v>
-                </c:pt>
-                <c:pt idx="5">
-                  <c:v>86.40853</c:v>
-                </c:pt>
-                <c:pt idx="6">
-                  <c:v>83.28291</c:v>
-                </c:pt>
-                <c:pt idx="7">
-                  <c:v>57.96047</c:v>
-                </c:pt>
-                <c:pt idx="8">
-                  <c:v>29.89517</c:v>
-                </c:pt>
-                <c:pt idx="9">
-                  <c:v>39.07102</c:v>
-                </c:pt>
-                <c:pt idx="10">
-                  <c:v>38.19532</c:v>
-                </c:pt>
-                <c:pt idx="11">
-                  <c:v>46.80238</c:v>
+                  <c:v>0.8</c:v>
                 </c:pt>
               </c:numCache>
             </c:numRef>
           </c:yVal>
           <c:bubbleSize>
-            <c:numRef>
-              <c:f>Sheet1!$C$10:$C$21</c:f>
-              <c:numCache>
-                <c:formatCode>General</c:formatCode>
-                <c:ptCount val="12"/>
-                <c:pt idx="0">
-                  <c:v>264.77134488858826</c:v>
-                </c:pt>
-                <c:pt idx="1">
-                  <c:v>56.54070304634169</c:v>
-                </c:pt>
-                <c:pt idx="2">
-                  <c:v>77.62481676610504</c:v>
-                </c:pt>
-                <c:pt idx="3">
-                  <c:v>36.96596667650137</c:v>
-                </c:pt>
-                <c:pt idx="4">
-                  <c:v>42.97360763888895</c:v>
-                </c:pt>
-                <c:pt idx="5">
-                  <c:v>35.78347270615566</c:v>
-                </c:pt>
-                <c:pt idx="6">
-                  <c:v>27.236483870967803</c:v>
-                </c:pt>
-                <c:pt idx="7">
-                  <c:v>11.025033851055353</c:v>
-                </c:pt>
-                <c:pt idx="8">
-                  <c:v>12.992016324817127</c:v>
-                </c:pt>
-                <c:pt idx="9">
-                  <c:v>6.741429369918694</c:v>
-                </c:pt>
-                <c:pt idx="10">
-                  <c:v>3.605855317396138</c:v>
-                </c:pt>
-                <c:pt idx="11">
-                  <c:v>2.1463333333333314</c:v>
-                </c:pt>
-              </c:numCache>
-            </c:numRef>
+            <c:numLit>
+              <c:formatCode>General</c:formatCode>
+              <c:ptCount val="3"/>
+              <c:pt idx="0">
+                <c:v>1</c:v>
+              </c:pt>
+              <c:pt idx="1">
+                <c:v>1</c:v>
+              </c:pt>
+              <c:pt idx="2">
+                <c:v>1</c:v>
+              </c:pt>
+            </c:numLit>
           </c:bubbleSize>
           <c:bubble3D val="0"/>
           <c:extLst>
@@ -1474,7 +753,6 @@
         <c:axId val="392045280"/>
         <c:scaling>
           <c:orientation val="minMax"/>
-          <c:min val="0.0"/>
         </c:scaling>
         <c:delete val="0"/>
         <c:axPos val="b"/>
@@ -1534,7 +812,6 @@
         <c:axId val="392046992"/>
         <c:scaling>
           <c:orientation val="minMax"/>
-          <c:min val="0.0"/>
         </c:scaling>
         <c:delete val="0"/>
         <c:axPos val="l"/>
@@ -2809,7 +2086,7 @@
           <a:p>
             <a:fld id="{C1255C68-584F-174D-BB81-51BF91708794}" type="datetimeFigureOut">
               <a:rPr lang="en-US" smtClean="0"/>
-              <a:t>3/12/26</a:t>
+              <a:t>3/20/26</a:t>
             </a:fld>
             <a:endParaRPr lang="en-US"/>
           </a:p>
@@ -2986,7 +2263,7 @@
           <a:p>
             <a:fld id="{A1EDAAC4-819D-C544-9EA1-C73624CFD70B}" type="datetimeFigureOut">
               <a:rPr lang="en-US" smtClean="0"/>
-              <a:t>3/12/26</a:t>
+              <a:t>3/20/26</a:t>
             </a:fld>
             <a:endParaRPr lang="en-US"/>
           </a:p>
@@ -23383,7 +22660,6 @@
               <a:rPr lang="en-US" dirty="0"/>
               <a:t>Software Quality report on Reportgeneratordemo</a:t>
             </a:r>
-            <a:endParaRPr lang="en-US" dirty="0"/>
           </a:p>
         </p:txBody>
       </p:sp>
@@ -23473,7 +22749,7 @@
           <a:p>
             <a:r>
               <a:rPr lang="en-US" dirty="0" err="1"/>
-              <a:t>March 08, 2026</a:t>
+              <a:t>March 20, 2026</a:t>
             </a:r>
             <a:endParaRPr lang="en-US" dirty="0"/>
           </a:p>
@@ -33249,7 +32525,7 @@
         </p:nvGraphicFramePr>
         <p:xfrm>
           <a:off x="937766" y="1466791"/>
-          <a:ext cx="10316468" cy="17341920"/>
+          <a:ext cx="10316468" cy="4540320"/>
         </p:xfrm>
         <a:graphic>
           <a:graphicData uri="http://schemas.openxmlformats.org/drawingml/2006/table">
@@ -40297,7 +39573,7 @@
       </p:sp>
       <p:graphicFrame>
         <p:nvGraphicFramePr>
-          <p:cNvPr id="8" name="TECHNICAL_DEBT_SYSTEMS_CHART">
+          <p:cNvPr id="8" name="TECHNICAL_DEBT_SYSTEMS_CHART&#13;&#10;">
             <a:extLst>
               <a:ext uri="{FF2B5EF4-FFF2-40B4-BE49-F238E27FC236}">
                 <a16:creationId xmlns:a16="http://schemas.microsoft.com/office/drawing/2014/main" id="{220D7F51-72F0-DC6F-B733-E9F269FA92FE}"/>
@@ -40308,7 +39584,7 @@
           <p:nvPr>
             <p:extLst>
               <p:ext uri="{D42A27DB-BD31-4B8C-83A1-F6EECF244321}">
-                <p14:modId xmlns:p14="http://schemas.microsoft.com/office/powerpoint/2010/main" val="1963346089"/>
+                <p14:modId xmlns:p14="http://schemas.microsoft.com/office/powerpoint/2010/main" val="94991413"/>
               </p:ext>
             </p:extLst>
           </p:nvPr>
@@ -40722,7 +39998,7 @@
       </p:sp>
       <p:graphicFrame>
         <p:nvGraphicFramePr>
-          <p:cNvPr id="10" name="MODERNIZATION_SCATTER_PLOT_CHART">
+          <p:cNvPr id="10" name="MODERNIZATION_SCATTER_PLOT_CHART&#13;&#10;">
             <a:extLst>
               <a:ext uri="{FF2B5EF4-FFF2-40B4-BE49-F238E27FC236}">
                 <a16:creationId xmlns:a16="http://schemas.microsoft.com/office/drawing/2014/main" id="{FA04012A-8076-57D9-16E6-FD4DB5AABD99}"/>
@@ -40733,7 +40009,7 @@
           <p:nvPr>
             <p:extLst>
               <p:ext uri="{D42A27DB-BD31-4B8C-83A1-F6EECF244321}">
-                <p14:modId xmlns:p14="http://schemas.microsoft.com/office/powerpoint/2010/main" val="2991213908"/>
+                <p14:modId xmlns:p14="http://schemas.microsoft.com/office/powerpoint/2010/main" val="1380179552"/>
               </p:ext>
             </p:extLst>
           </p:nvPr>
@@ -41883,6 +41159,26 @@
 </file>
 
 <file path=customXml/item1.xml><?xml version="1.0" encoding="utf-8"?>
+<?mso-contentType ?>
+<FormTemplates xmlns="http://schemas.microsoft.com/sharepoint/v3/contenttype/forms">
+  <Display>DocumentLibraryForm</Display>
+  <Edit>DocumentLibraryForm</Edit>
+  <New>DocumentLibraryForm</New>
+</FormTemplates>
+</file>
+
+<file path=customXml/item2.xml><?xml version="1.0" encoding="utf-8"?>
+<p:properties xmlns:p="http://schemas.microsoft.com/office/2006/metadata/properties" xmlns:xsi="http://www.w3.org/2001/XMLSchema-instance" xmlns:pc="http://schemas.microsoft.com/office/infopath/2007/PartnerControls">
+  <documentManagement>
+    <lcf76f155ced4ddcb4097134ff3c332f xmlns="fa937df2-abe2-4d38-b5f4-c228acba3827">
+      <Terms xmlns="http://schemas.microsoft.com/office/infopath/2007/PartnerControls"/>
+    </lcf76f155ced4ddcb4097134ff3c332f>
+    <TaxCatchAll xmlns="bc8ba18a-4a58-4ad2-bfc0-6516af8e7dc2" xsi:nil="true"/>
+  </documentManagement>
+</p:properties>
+</file>
+
+<file path=customXml/item3.xml><?xml version="1.0" encoding="utf-8"?>
 <ct:contentTypeSchema xmlns:ct="http://schemas.microsoft.com/office/2006/metadata/contentType" xmlns:ma="http://schemas.microsoft.com/office/2006/metadata/properties/metaAttributes" ct:_="" ma:_="" ma:contentTypeName="Document" ma:contentTypeID="0x010100398B4EB28540854BB4092730D7F67224" ma:contentTypeVersion="13" ma:contentTypeDescription="Create a new document." ma:contentTypeScope="" ma:versionID="07d6997c7358ecc3b6f0d78039f1ac55">
   <xsd:schema xmlns:xsd="http://www.w3.org/2001/XMLSchema" xmlns:xs="http://www.w3.org/2001/XMLSchema" xmlns:p="http://schemas.microsoft.com/office/2006/metadata/properties" xmlns:ns2="fa937df2-abe2-4d38-b5f4-c228acba3827" xmlns:ns3="bc8ba18a-4a58-4ad2-bfc0-6516af8e7dc2" targetNamespace="http://schemas.microsoft.com/office/2006/metadata/properties" ma:root="true" ma:fieldsID="a7d20d2c9a349b6838acf4b79389f2fd" ns2:_="" ns3:_="">
     <xsd:import namespace="fa937df2-abe2-4d38-b5f4-c228acba3827"/>
@@ -42105,27 +41401,32 @@
 </ct:contentTypeSchema>
 </file>
 
-<file path=customXml/item2.xml><?xml version="1.0" encoding="utf-8"?>
-<?mso-contentType ?>
-<FormTemplates xmlns="http://schemas.microsoft.com/sharepoint/v3/contenttype/forms">
-  <Display>DocumentLibraryForm</Display>
-  <Edit>DocumentLibraryForm</Edit>
-  <New>DocumentLibraryForm</New>
-</FormTemplates>
+<file path=customXml/itemProps1.xml><?xml version="1.0" encoding="utf-8"?>
+<ds:datastoreItem xmlns:ds="http://schemas.openxmlformats.org/officeDocument/2006/customXml" ds:itemID="{570928F0-D7CA-4732-B7F3-1F945720D0AA}">
+  <ds:schemaRefs>
+    <ds:schemaRef ds:uri="http://schemas.microsoft.com/sharepoint/v3/contenttype/forms"/>
+  </ds:schemaRefs>
+</ds:datastoreItem>
 </file>
 
-<file path=customXml/item3.xml><?xml version="1.0" encoding="utf-8"?>
-<p:properties xmlns:p="http://schemas.microsoft.com/office/2006/metadata/properties" xmlns:xsi="http://www.w3.org/2001/XMLSchema-instance" xmlns:pc="http://schemas.microsoft.com/office/infopath/2007/PartnerControls">
-  <documentManagement>
-    <lcf76f155ced4ddcb4097134ff3c332f xmlns="fa937df2-abe2-4d38-b5f4-c228acba3827">
-      <Terms xmlns="http://schemas.microsoft.com/office/infopath/2007/PartnerControls"/>
-    </lcf76f155ced4ddcb4097134ff3c332f>
-    <TaxCatchAll xmlns="bc8ba18a-4a58-4ad2-bfc0-6516af8e7dc2" xsi:nil="true"/>
-  </documentManagement>
-</p:properties>
+<file path=customXml/itemProps2.xml><?xml version="1.0" encoding="utf-8"?>
+<ds:datastoreItem xmlns:ds="http://schemas.openxmlformats.org/officeDocument/2006/customXml" ds:itemID="{4B629362-CF15-4610-8FAC-A8E699942233}">
+  <ds:schemaRefs>
+    <ds:schemaRef ds:uri="http://schemas.microsoft.com/office/2006/documentManagement/types"/>
+    <ds:schemaRef ds:uri="http://purl.org/dc/elements/1.1/"/>
+    <ds:schemaRef ds:uri="bc8ba18a-4a58-4ad2-bfc0-6516af8e7dc2"/>
+    <ds:schemaRef ds:uri="http://purl.org/dc/terms/"/>
+    <ds:schemaRef ds:uri="http://www.w3.org/XML/1998/namespace"/>
+    <ds:schemaRef ds:uri="http://schemas.microsoft.com/office/2006/metadata/properties"/>
+    <ds:schemaRef ds:uri="http://schemas.microsoft.com/office/infopath/2007/PartnerControls"/>
+    <ds:schemaRef ds:uri="http://schemas.openxmlformats.org/package/2006/metadata/core-properties"/>
+    <ds:schemaRef ds:uri="fa937df2-abe2-4d38-b5f4-c228acba3827"/>
+    <ds:schemaRef ds:uri="http://purl.org/dc/dcmitype/"/>
+  </ds:schemaRefs>
+</ds:datastoreItem>
 </file>
 
-<file path=customXml/itemProps1.xml><?xml version="1.0" encoding="utf-8"?>
+<file path=customXml/itemProps3.xml><?xml version="1.0" encoding="utf-8"?>
 <ds:datastoreItem xmlns:ds="http://schemas.openxmlformats.org/officeDocument/2006/customXml" ds:itemID="{06E6923A-C221-4753-B75B-BA213EEB7564}">
   <ds:schemaRefs>
     <ds:schemaRef ds:uri="bc8ba18a-4a58-4ad2-bfc0-6516af8e7dc2"/>
@@ -42142,29 +41443,4 @@
     <ds:schemaRef ds:uri="http://www.w3.org/2001/XMLSchema"/>
   </ds:schemaRefs>
 </ds:datastoreItem>
-</file>
-
-<file path=customXml/itemProps2.xml><?xml version="1.0" encoding="utf-8"?>
-<ds:datastoreItem xmlns:ds="http://schemas.openxmlformats.org/officeDocument/2006/customXml" ds:itemID="{570928F0-D7CA-4732-B7F3-1F945720D0AA}">
-  <ds:schemaRefs>
-    <ds:schemaRef ds:uri="http://schemas.microsoft.com/sharepoint/v3/contenttype/forms"/>
-  </ds:schemaRefs>
-</ds:datastoreItem>
-</file>
-
-<file path=customXml/itemProps3.xml><?xml version="1.0" encoding="utf-8"?>
-<ds:datastoreItem xmlns:ds="http://schemas.openxmlformats.org/officeDocument/2006/customXml" ds:itemID="{4B629362-CF15-4610-8FAC-A8E699942233}">
-  <ds:schemaRefs>
-    <ds:schemaRef ds:uri="http://schemas.microsoft.com/office/2006/documentManagement/types"/>
-    <ds:schemaRef ds:uri="http://purl.org/dc/elements/1.1/"/>
-    <ds:schemaRef ds:uri="bc8ba18a-4a58-4ad2-bfc0-6516af8e7dc2"/>
-    <ds:schemaRef ds:uri="http://purl.org/dc/terms/"/>
-    <ds:schemaRef ds:uri="http://www.w3.org/XML/1998/namespace"/>
-    <ds:schemaRef ds:uri="http://schemas.microsoft.com/office/2006/metadata/properties"/>
-    <ds:schemaRef ds:uri="http://schemas.microsoft.com/office/infopath/2007/PartnerControls"/>
-    <ds:schemaRef ds:uri="http://schemas.openxmlformats.org/package/2006/metadata/core-properties"/>
-    <ds:schemaRef ds:uri="fa937df2-abe2-4d38-b5f4-c228acba3827"/>
-    <ds:schemaRef ds:uri="http://purl.org/dc/dcmitype/"/>
-  </ds:schemaRefs>
-</ds:datastoreItem>
 </file>
</xml_diff>

<commit_message>
Regen reference for confirmed no unexpected changes (all except portfolio-overview)
</commit_message>
<xml_diff>
--- a/report-generator/tests/report_generator/integration/references/reference_modernization.pptx
+++ b/report-generator/tests/report_generator/integration/references/reference_modernization.pptx
@@ -317,22 +317,22 @@
                   <c:v>138.76191</c:v>
                 </c:pt>
                 <c:pt idx="1">
-                  <c:v>34.857190000000003</c:v>
+                  <c:v>34.85719</c:v>
                 </c:pt>
                 <c:pt idx="2">
-                  <c:v>24.574729999999999</c:v>
+                  <c:v>24.57473</c:v>
                 </c:pt>
                 <c:pt idx="3">
                   <c:v>18.88447</c:v>
                 </c:pt>
                 <c:pt idx="4">
-                  <c:v>18.380690000000001</c:v>
+                  <c:v>18.38069</c:v>
                 </c:pt>
                 <c:pt idx="5">
                   <c:v>18.16938</c:v>
                 </c:pt>
                 <c:pt idx="6">
-                  <c:v>12.486520000000001</c:v>
+                  <c:v>12.48652</c:v>
                 </c:pt>
                 <c:pt idx="7">
                   <c:v>3.17265</c:v>
@@ -344,10 +344,10 @@
                   <c:v>1.53173</c:v>
                 </c:pt>
                 <c:pt idx="10">
-                  <c:v>1.0407200000000001</c:v>
+                  <c:v>1.04072</c:v>
                 </c:pt>
                 <c:pt idx="11">
-                  <c:v>0.52361999999999997</c:v>
+                  <c:v>0.52362</c:v>
                 </c:pt>
               </c:numCache>
             </c:numRef>
@@ -442,7 +442,7 @@
                   <c:v>12.391236676501368</c:v>
                 </c:pt>
                 <c:pt idx="3">
-                  <c:v>58.740346766105041</c:v>
+                  <c:v>58.74034676610504</c:v>
                 </c:pt>
                 <c:pt idx="4">
                   <c:v>17.402782706155662</c:v>
@@ -454,10 +454,10 @@
                   <c:v>14.749963870967802</c:v>
                 </c:pt>
                 <c:pt idx="7">
-                  <c:v>9.8193663248171283</c:v>
+                  <c:v>9.819366324817128</c:v>
                 </c:pt>
                 <c:pt idx="8">
-                  <c:v>8.3327238510553521</c:v>
+                  <c:v>8.332723851055352</c:v>
                 </c:pt>
                 <c:pt idx="9">
                   <c:v>5.2096993699186935</c:v>
@@ -663,7 +663,7 @@
               <c:strCache>
                 <c:ptCount val="1"/>
                 <c:pt idx="0">
-                  <c:v>Estimated change speed increase</c:v>
+                  <c:v>Critical</c:v>
                 </c:pt>
               </c:strCache>
             </c:strRef>
@@ -680,54 +680,775 @@
           <c:invertIfNegative val="0"/>
           <c:xVal>
             <c:numRef>
-              <c:f>Sheet1!$A$2:$A$4</c:f>
+              <c:f>Sheet1!$A$2:$A$1</c:f>
               <c:numCache>
                 <c:formatCode>General</c:formatCode>
-                <c:ptCount val="3"/>
+                <c:ptCount val="0"/>
+              </c:numCache>
+            </c:numRef>
+          </c:xVal>
+          <c:yVal>
+            <c:numRef>
+              <c:f>Sheet1!$B$2:$B$1</c:f>
+              <c:numCache>
+                <c:formatCode>General</c:formatCode>
+                <c:ptCount val="0"/>
+              </c:numCache>
+            </c:numRef>
+          </c:yVal>
+          <c:bubbleSize>
+            <c:numRef>
+              <c:f>Sheet1!$C$2:$C$1</c:f>
+              <c:numCache>
+                <c:formatCode>General</c:formatCode>
+                <c:ptCount val="0"/>
+              </c:numCache>
+            </c:numRef>
+          </c:bubbleSize>
+          <c:bubble3D val="0"/>
+          <c:extLst>
+            <c:ext xmlns:c16="http://schemas.microsoft.com/office/drawing/2014/chart" uri="{C3380CC4-5D6E-409C-BE32-E72D297353CC}">
+              <c16:uniqueId val="{00000000-D4B8-B94C-91E4-2DDF998DBB50}"/>
+            </c:ext>
+          </c:extLst>
+        </c:ser>
+        <c:ser>
+          <c:idx val="1"/>
+          <c:order val="1"/>
+          <c:tx>
+            <c:strRef>
+              <c:f>Sheet1!$B$3</c:f>
+              <c:strCache>
+                <c:ptCount val="1"/>
                 <c:pt idx="0">
-                  <c:v>0.7</c:v>
+                  <c:v>High</c:v>
+                </c:pt>
+              </c:strCache>
+            </c:strRef>
+          </c:tx>
+          <c:spPr>
+            <a:solidFill>
+              <a:schemeClr val="accent1"/>
+            </a:solidFill>
+            <a:ln w="19050">
+              <a:noFill/>
+            </a:ln>
+            <a:effectLst/>
+          </c:spPr>
+          <c:invertIfNegative val="0"/>
+          <c:xVal>
+            <c:numRef>
+              <c:f>Sheet1!$A$4:$A$3</c:f>
+              <c:numCache>
+                <c:formatCode>General</c:formatCode>
+                <c:ptCount val="0"/>
+              </c:numCache>
+            </c:numRef>
+          </c:xVal>
+          <c:yVal>
+            <c:numRef>
+              <c:f>Sheet1!$B$4:$B$3</c:f>
+              <c:numCache>
+                <c:formatCode>General</c:formatCode>
+                <c:ptCount val="0"/>
+              </c:numCache>
+            </c:numRef>
+          </c:yVal>
+          <c:bubbleSize>
+            <c:numRef>
+              <c:f>Sheet1!$C$4:$C$3</c:f>
+              <c:numCache>
+                <c:formatCode>General</c:formatCode>
+                <c:ptCount val="0"/>
+              </c:numCache>
+            </c:numRef>
+          </c:bubbleSize>
+          <c:bubble3D val="0"/>
+          <c:extLst>
+            <c:ext xmlns:c16="http://schemas.microsoft.com/office/drawing/2014/chart" uri="{C3380CC4-5D6E-409C-BE32-E72D297353CC}">
+              <c16:uniqueId val="{00000000-D4B8-B94C-91E4-2DDF998DBB50}"/>
+            </c:ext>
+          </c:extLst>
+        </c:ser>
+        <c:ser>
+          <c:idx val="2"/>
+          <c:order val="2"/>
+          <c:tx>
+            <c:strRef>
+              <c:f>Sheet1!$B$5</c:f>
+              <c:strCache>
+                <c:ptCount val="1"/>
+                <c:pt idx="0">
+                  <c:v>Medium</c:v>
+                </c:pt>
+              </c:strCache>
+            </c:strRef>
+          </c:tx>
+          <c:spPr>
+            <a:solidFill>
+              <a:schemeClr val="accent1"/>
+            </a:solidFill>
+            <a:ln w="19050">
+              <a:noFill/>
+            </a:ln>
+            <a:effectLst/>
+          </c:spPr>
+          <c:invertIfNegative val="0"/>
+          <c:xVal>
+            <c:numRef>
+              <c:f>Sheet1!$A$6:$A$5</c:f>
+              <c:numCache>
+                <c:formatCode>General</c:formatCode>
+                <c:ptCount val="0"/>
+              </c:numCache>
+            </c:numRef>
+          </c:xVal>
+          <c:yVal>
+            <c:numRef>
+              <c:f>Sheet1!$B$6:$B$5</c:f>
+              <c:numCache>
+                <c:formatCode>General</c:formatCode>
+                <c:ptCount val="0"/>
+              </c:numCache>
+            </c:numRef>
+          </c:yVal>
+          <c:bubbleSize>
+            <c:numRef>
+              <c:f>Sheet1!$C$6:$C$5</c:f>
+              <c:numCache>
+                <c:formatCode>General</c:formatCode>
+                <c:ptCount val="0"/>
+              </c:numCache>
+            </c:numRef>
+          </c:bubbleSize>
+          <c:bubble3D val="0"/>
+          <c:extLst>
+            <c:ext xmlns:c16="http://schemas.microsoft.com/office/drawing/2014/chart" uri="{C3380CC4-5D6E-409C-BE32-E72D297353CC}">
+              <c16:uniqueId val="{00000000-D4B8-B94C-91E4-2DDF998DBB50}"/>
+            </c:ext>
+          </c:extLst>
+        </c:ser>
+        <c:ser>
+          <c:idx val="3"/>
+          <c:order val="3"/>
+          <c:tx>
+            <c:strRef>
+              <c:f>Sheet1!$B$7</c:f>
+              <c:strCache>
+                <c:ptCount val="1"/>
+                <c:pt idx="0">
+                  <c:v>Low</c:v>
+                </c:pt>
+              </c:strCache>
+            </c:strRef>
+          </c:tx>
+          <c:spPr>
+            <a:solidFill>
+              <a:schemeClr val="accent1"/>
+            </a:solidFill>
+            <a:ln w="19050">
+              <a:noFill/>
+            </a:ln>
+            <a:effectLst/>
+          </c:spPr>
+          <c:invertIfNegative val="0"/>
+          <c:xVal>
+            <c:numRef>
+              <c:f>Sheet1!$A$8:$A$7</c:f>
+              <c:numCache>
+                <c:formatCode>General</c:formatCode>
+                <c:ptCount val="0"/>
+              </c:numCache>
+            </c:numRef>
+          </c:xVal>
+          <c:yVal>
+            <c:numRef>
+              <c:f>Sheet1!$B$8:$B$7</c:f>
+              <c:numCache>
+                <c:formatCode>General</c:formatCode>
+                <c:ptCount val="0"/>
+              </c:numCache>
+            </c:numRef>
+          </c:yVal>
+          <c:bubbleSize>
+            <c:numRef>
+              <c:f>Sheet1!$C$8:$C$7</c:f>
+              <c:numCache>
+                <c:formatCode>General</c:formatCode>
+                <c:ptCount val="0"/>
+              </c:numCache>
+            </c:numRef>
+          </c:bubbleSize>
+          <c:bubble3D val="0"/>
+          <c:extLst>
+            <c:ext xmlns:c16="http://schemas.microsoft.com/office/drawing/2014/chart" uri="{C3380CC4-5D6E-409C-BE32-E72D297353CC}">
+              <c16:uniqueId val="{00000000-D4B8-B94C-91E4-2DDF998DBB50}"/>
+            </c:ext>
+          </c:extLst>
+        </c:ser>
+        <c:ser>
+          <c:idx val="4"/>
+          <c:order val="4"/>
+          <c:tx>
+            <c:strRef>
+              <c:f>Sheet1!$B$9</c:f>
+              <c:strCache>
+                <c:ptCount val="1"/>
+                <c:pt idx="0">
+                  <c:v>Unknown</c:v>
+                </c:pt>
+              </c:strCache>
+            </c:strRef>
+          </c:tx>
+          <c:spPr>
+            <a:solidFill>
+              <a:schemeClr val="accent1"/>
+            </a:solidFill>
+            <a:ln w="19050">
+              <a:noFill/>
+            </a:ln>
+            <a:effectLst/>
+          </c:spPr>
+          <c:invertIfNegative val="0"/>
+          <c:dPt>
+            <c:idx val="0"/>
+            <c:spPr>
+              <a:solidFill>
+                <a:srgbClr val="8A98A8"/>
+              </a:solidFill>
+              <a:ln>
+                <a:solidFill>
+                  <a:srgbClr val="FFFFFF"/>
+                </a:solidFill>
+              </a:ln>
+            </c:spPr>
+          </c:dPt>
+          <c:dPt>
+            <c:idx val="1"/>
+            <c:spPr>
+              <a:solidFill>
+                <a:srgbClr val="8A98A8"/>
+              </a:solidFill>
+              <a:ln>
+                <a:solidFill>
+                  <a:srgbClr val="FFFFFF"/>
+                </a:solidFill>
+              </a:ln>
+            </c:spPr>
+          </c:dPt>
+          <c:dPt>
+            <c:idx val="2"/>
+            <c:spPr>
+              <a:solidFill>
+                <a:srgbClr val="8A98A8"/>
+              </a:solidFill>
+              <a:ln>
+                <a:solidFill>
+                  <a:srgbClr val="FFFFFF"/>
+                </a:solidFill>
+              </a:ln>
+            </c:spPr>
+          </c:dPt>
+          <c:dPt>
+            <c:idx val="3"/>
+            <c:spPr>
+              <a:solidFill>
+                <a:srgbClr val="8A98A8"/>
+              </a:solidFill>
+              <a:ln>
+                <a:solidFill>
+                  <a:srgbClr val="FFFFFF"/>
+                </a:solidFill>
+              </a:ln>
+            </c:spPr>
+          </c:dPt>
+          <c:dPt>
+            <c:idx val="4"/>
+            <c:spPr>
+              <a:solidFill>
+                <a:srgbClr val="8A98A8"/>
+              </a:solidFill>
+              <a:ln>
+                <a:solidFill>
+                  <a:srgbClr val="FFFFFF"/>
+                </a:solidFill>
+              </a:ln>
+            </c:spPr>
+          </c:dPt>
+          <c:dPt>
+            <c:idx val="5"/>
+            <c:spPr>
+              <a:solidFill>
+                <a:srgbClr val="8A98A8"/>
+              </a:solidFill>
+              <a:ln>
+                <a:solidFill>
+                  <a:srgbClr val="FFFFFF"/>
+                </a:solidFill>
+              </a:ln>
+            </c:spPr>
+          </c:dPt>
+          <c:dPt>
+            <c:idx val="6"/>
+            <c:spPr>
+              <a:solidFill>
+                <a:srgbClr val="8A98A8"/>
+              </a:solidFill>
+              <a:ln>
+                <a:solidFill>
+                  <a:srgbClr val="FFFFFF"/>
+                </a:solidFill>
+              </a:ln>
+            </c:spPr>
+          </c:dPt>
+          <c:dPt>
+            <c:idx val="7"/>
+            <c:spPr>
+              <a:solidFill>
+                <a:srgbClr val="8A98A8"/>
+              </a:solidFill>
+              <a:ln>
+                <a:solidFill>
+                  <a:srgbClr val="FFFFFF"/>
+                </a:solidFill>
+              </a:ln>
+            </c:spPr>
+          </c:dPt>
+          <c:dPt>
+            <c:idx val="8"/>
+            <c:spPr>
+              <a:solidFill>
+                <a:srgbClr val="8A98A8"/>
+              </a:solidFill>
+              <a:ln>
+                <a:solidFill>
+                  <a:srgbClr val="FFFFFF"/>
+                </a:solidFill>
+              </a:ln>
+            </c:spPr>
+          </c:dPt>
+          <c:dPt>
+            <c:idx val="9"/>
+            <c:spPr>
+              <a:solidFill>
+                <a:srgbClr val="8A98A8"/>
+              </a:solidFill>
+              <a:ln>
+                <a:solidFill>
+                  <a:srgbClr val="FFFFFF"/>
+                </a:solidFill>
+              </a:ln>
+            </c:spPr>
+          </c:dPt>
+          <c:dPt>
+            <c:idx val="10"/>
+            <c:spPr>
+              <a:solidFill>
+                <a:srgbClr val="8A98A8"/>
+              </a:solidFill>
+              <a:ln>
+                <a:solidFill>
+                  <a:srgbClr val="FFFFFF"/>
+                </a:solidFill>
+              </a:ln>
+            </c:spPr>
+          </c:dPt>
+          <c:dPt>
+            <c:idx val="11"/>
+            <c:spPr>
+              <a:solidFill>
+                <a:srgbClr val="8A98A8"/>
+              </a:solidFill>
+              <a:ln>
+                <a:solidFill>
+                  <a:srgbClr val="FFFFFF"/>
+                </a:solidFill>
+              </a:ln>
+            </c:spPr>
+          </c:dPt>
+          <c:dLbls>
+            <c:dLbl>
+              <c:idx val="0"/>
+              <c:tx>
+                <c:rich>
+                  <a:bodyPr/>
+                  <a:lstStyle/>
+                  <a:p>
+                    <a:r>
+                      <a:t>integrationtest-elasticsearch</a:t>
+                    </a:r>
+                  </a:p>
+                </c:rich>
+              </c:tx>
+              <c:showLegendKey val="0"/>
+              <c:showVal val="1"/>
+              <c:showCatName val="0"/>
+              <c:showSerName val="0"/>
+              <c:showPercent val="0"/>
+              <c:showBubbleSize val="0"/>
+            </c:dLbl>
+            <c:dLbl>
+              <c:idx val="1"/>
+              <c:tx>
+                <c:rich>
+                  <a:bodyPr/>
+                  <a:lstStyle/>
+                  <a:p>
+                    <a:r>
+                      <a:t>integrationtest-airflow</a:t>
+                    </a:r>
+                  </a:p>
+                </c:rich>
+              </c:tx>
+              <c:showLegendKey val="0"/>
+              <c:showVal val="1"/>
+              <c:showCatName val="0"/>
+              <c:showSerName val="0"/>
+              <c:showPercent val="0"/>
+              <c:showBubbleSize val="0"/>
+            </c:dLbl>
+            <c:dLbl>
+              <c:idx val="2"/>
+              <c:tx>
+                <c:rich>
+                  <a:bodyPr/>
+                  <a:lstStyle/>
+                  <a:p>
+                    <a:r>
+                      <a:t>integrationtest-vscode</a:t>
+                    </a:r>
+                  </a:p>
+                </c:rich>
+              </c:tx>
+              <c:showLegendKey val="0"/>
+              <c:showVal val="1"/>
+              <c:showCatName val="0"/>
+              <c:showSerName val="0"/>
+              <c:showPercent val="0"/>
+              <c:showBubbleSize val="0"/>
+            </c:dLbl>
+            <c:dLbl>
+              <c:idx val="3"/>
+              <c:tx>
+                <c:rich>
+                  <a:bodyPr/>
+                  <a:lstStyle/>
+                  <a:p>
+                    <a:r>
+                      <a:t>integrationtest-git</a:t>
+                    </a:r>
+                  </a:p>
+                </c:rich>
+              </c:tx>
+              <c:showLegendKey val="0"/>
+              <c:showVal val="1"/>
+              <c:showCatName val="0"/>
+              <c:showSerName val="0"/>
+              <c:showPercent val="0"/>
+              <c:showBubbleSize val="0"/>
+            </c:dLbl>
+            <c:dLbl>
+              <c:idx val="4"/>
+              <c:tx>
+                <c:rich>
+                  <a:bodyPr/>
+                  <a:lstStyle/>
+                  <a:p>
+                    <a:r>
+                      <a:t>integrationtest-kafka</a:t>
+                    </a:r>
+                  </a:p>
+                </c:rich>
+              </c:tx>
+              <c:showLegendKey val="0"/>
+              <c:showVal val="1"/>
+              <c:showCatName val="0"/>
+              <c:showSerName val="0"/>
+              <c:showPercent val="0"/>
+              <c:showBubbleSize val="0"/>
+            </c:dLbl>
+            <c:dLbl>
+              <c:idx val="5"/>
+              <c:tx>
+                <c:rich>
+                  <a:bodyPr/>
+                  <a:lstStyle/>
+                  <a:p>
+                    <a:r>
+                      <a:t>integrationtest-jruby</a:t>
+                    </a:r>
+                  </a:p>
+                </c:rich>
+              </c:tx>
+              <c:showLegendKey val="0"/>
+              <c:showVal val="1"/>
+              <c:showCatName val="0"/>
+              <c:showSerName val="0"/>
+              <c:showPercent val="0"/>
+              <c:showBubbleSize val="0"/>
+            </c:dLbl>
+            <c:dLbl>
+              <c:idx val="6"/>
+              <c:tx>
+                <c:rich>
+                  <a:bodyPr/>
+                  <a:lstStyle/>
+                  <a:p>
+                    <a:r>
+                      <a:t>integrationtest-druid</a:t>
+                    </a:r>
+                  </a:p>
+                </c:rich>
+              </c:tx>
+              <c:showLegendKey val="0"/>
+              <c:showVal val="1"/>
+              <c:showCatName val="0"/>
+              <c:showSerName val="0"/>
+              <c:showPercent val="0"/>
+              <c:showBubbleSize val="0"/>
+            </c:dLbl>
+            <c:dLbl>
+              <c:idx val="7"/>
+              <c:tx>
+                <c:rich>
+                  <a:bodyPr/>
+                  <a:lstStyle/>
+                  <a:p>
+                    <a:r>
+                      <a:t>integrationtest-webpack</a:t>
+                    </a:r>
+                  </a:p>
+                </c:rich>
+              </c:tx>
+              <c:showLegendKey val="0"/>
+              <c:showVal val="1"/>
+              <c:showCatName val="0"/>
+              <c:showSerName val="0"/>
+              <c:showPercent val="0"/>
+              <c:showBubbleSize val="0"/>
+            </c:dLbl>
+            <c:dLbl>
+              <c:idx val="8"/>
+              <c:tx>
+                <c:rich>
+                  <a:bodyPr/>
+                  <a:lstStyle/>
+                  <a:p>
+                    <a:r>
+                      <a:t>integrationtest-electron</a:t>
+                    </a:r>
+                  </a:p>
+                </c:rich>
+              </c:tx>
+              <c:showLegendKey val="0"/>
+              <c:showVal val="1"/>
+              <c:showCatName val="0"/>
+              <c:showSerName val="0"/>
+              <c:showPercent val="0"/>
+              <c:showBubbleSize val="0"/>
+            </c:dLbl>
+            <c:dLbl>
+              <c:idx val="9"/>
+              <c:tx>
+                <c:rich>
+                  <a:bodyPr/>
+                  <a:lstStyle/>
+                  <a:p>
+                    <a:r>
+                      <a:t>integrationtest-bazel</a:t>
+                    </a:r>
+                  </a:p>
+                </c:rich>
+              </c:tx>
+              <c:showLegendKey val="0"/>
+              <c:showVal val="1"/>
+              <c:showCatName val="0"/>
+              <c:showSerName val="0"/>
+              <c:showPercent val="0"/>
+              <c:showBubbleSize val="0"/>
+            </c:dLbl>
+            <c:dLbl>
+              <c:idx val="10"/>
+              <c:tx>
+                <c:rich>
+                  <a:bodyPr/>
+                  <a:lstStyle/>
+                  <a:p>
+                    <a:r>
+                      <a:t>integrationtest-facebookyoga</a:t>
+                    </a:r>
+                  </a:p>
+                </c:rich>
+              </c:tx>
+              <c:showLegendKey val="0"/>
+              <c:showVal val="1"/>
+              <c:showCatName val="0"/>
+              <c:showSerName val="0"/>
+              <c:showPercent val="0"/>
+              <c:showBubbleSize val="0"/>
+            </c:dLbl>
+            <c:dLbl>
+              <c:idx val="11"/>
+              <c:tx>
+                <c:rich>
+                  <a:bodyPr/>
+                  <a:lstStyle/>
+                  <a:p>
+                    <a:r>
+                      <a:t>integrationtest-zuul</a:t>
+                    </a:r>
+                  </a:p>
+                </c:rich>
+              </c:tx>
+              <c:showLegendKey val="0"/>
+              <c:showVal val="1"/>
+              <c:showCatName val="0"/>
+              <c:showSerName val="0"/>
+              <c:showPercent val="0"/>
+              <c:showBubbleSize val="0"/>
+            </c:dLbl>
+            <c:showLegendKey val="0"/>
+            <c:showVal val="0"/>
+            <c:showCatName val="0"/>
+            <c:showSerName val="0"/>
+            <c:showPercent val="0"/>
+            <c:showBubbleSize val="0"/>
+            <c:showLeaderLines val="1"/>
+          </c:dLbls>
+          <c:xVal>
+            <c:numRef>
+              <c:f>Sheet1!$A$10:$A$21</c:f>
+              <c:numCache>
+                <c:formatCode>General</c:formatCode>
+                <c:ptCount val="12"/>
+                <c:pt idx="0">
+                  <c:v>138.76191</c:v>
                 </c:pt>
                 <c:pt idx="1">
-                  <c:v>1.8</c:v>
+                  <c:v>34.85719</c:v>
                 </c:pt>
                 <c:pt idx="2">
-                  <c:v>2.6</c:v>
+                  <c:v>18.88447</c:v>
+                </c:pt>
+                <c:pt idx="3">
+                  <c:v>24.57473</c:v>
+                </c:pt>
+                <c:pt idx="4">
+                  <c:v>18.16938</c:v>
+                </c:pt>
+                <c:pt idx="5">
+                  <c:v>18.38069</c:v>
+                </c:pt>
+                <c:pt idx="6">
+                  <c:v>12.48652</c:v>
+                </c:pt>
+                <c:pt idx="7">
+                  <c:v>2.69231</c:v>
+                </c:pt>
+                <c:pt idx="8">
+                  <c:v>3.17265</c:v>
+                </c:pt>
+                <c:pt idx="9">
+                  <c:v>1.53173</c:v>
+                </c:pt>
+                <c:pt idx="10">
+                  <c:v>1.04072</c:v>
+                </c:pt>
+                <c:pt idx="11">
+                  <c:v>0.52362</c:v>
                 </c:pt>
               </c:numCache>
             </c:numRef>
           </c:xVal>
           <c:yVal>
             <c:numRef>
-              <c:f>Sheet1!$B$2:$B$4</c:f>
+              <c:f>Sheet1!$B$10:$B$21</c:f>
               <c:numCache>
-                <c:formatCode>0%</c:formatCode>
-                <c:ptCount val="3"/>
+                <c:formatCode>General</c:formatCode>
+                <c:ptCount val="12"/>
                 <c:pt idx="0">
-                  <c:v>2.7</c:v>
+                  <c:v>88.2573</c:v>
                 </c:pt>
                 <c:pt idx="1">
-                  <c:v>3.2</c:v>
+                  <c:v>80.33779</c:v>
                 </c:pt>
                 <c:pt idx="2">
-                  <c:v>0.8</c:v>
+                  <c:v>46.60242</c:v>
+                </c:pt>
+                <c:pt idx="3">
+                  <c:v>96.01779</c:v>
+                </c:pt>
+                <c:pt idx="4">
+                  <c:v>77.13151</c:v>
+                </c:pt>
+                <c:pt idx="5">
+                  <c:v>86.40853</c:v>
+                </c:pt>
+                <c:pt idx="6">
+                  <c:v>83.28291</c:v>
+                </c:pt>
+                <c:pt idx="7">
+                  <c:v>57.96047</c:v>
+                </c:pt>
+                <c:pt idx="8">
+                  <c:v>29.89517</c:v>
+                </c:pt>
+                <c:pt idx="9">
+                  <c:v>39.07102</c:v>
+                </c:pt>
+                <c:pt idx="10">
+                  <c:v>38.19532</c:v>
+                </c:pt>
+                <c:pt idx="11">
+                  <c:v>46.80238</c:v>
                 </c:pt>
               </c:numCache>
             </c:numRef>
           </c:yVal>
           <c:bubbleSize>
-            <c:numLit>
-              <c:formatCode>General</c:formatCode>
-              <c:ptCount val="3"/>
-              <c:pt idx="0">
-                <c:v>1</c:v>
-              </c:pt>
-              <c:pt idx="1">
-                <c:v>1</c:v>
-              </c:pt>
-              <c:pt idx="2">
-                <c:v>1</c:v>
-              </c:pt>
-            </c:numLit>
+            <c:numRef>
+              <c:f>Sheet1!$C$10:$C$21</c:f>
+              <c:numCache>
+                <c:formatCode>General</c:formatCode>
+                <c:ptCount val="12"/>
+                <c:pt idx="0">
+                  <c:v>264.77134488858826</c:v>
+                </c:pt>
+                <c:pt idx="1">
+                  <c:v>56.54070304634169</c:v>
+                </c:pt>
+                <c:pt idx="2">
+                  <c:v>77.62481676610504</c:v>
+                </c:pt>
+                <c:pt idx="3">
+                  <c:v>36.96596667650137</c:v>
+                </c:pt>
+                <c:pt idx="4">
+                  <c:v>42.97360763888895</c:v>
+                </c:pt>
+                <c:pt idx="5">
+                  <c:v>35.78347270615566</c:v>
+                </c:pt>
+                <c:pt idx="6">
+                  <c:v>27.236483870967803</c:v>
+                </c:pt>
+                <c:pt idx="7">
+                  <c:v>11.025033851055353</c:v>
+                </c:pt>
+                <c:pt idx="8">
+                  <c:v>12.992016324817127</c:v>
+                </c:pt>
+                <c:pt idx="9">
+                  <c:v>6.741429369918694</c:v>
+                </c:pt>
+                <c:pt idx="10">
+                  <c:v>3.605855317396138</c:v>
+                </c:pt>
+                <c:pt idx="11">
+                  <c:v>2.1463333333333314</c:v>
+                </c:pt>
+              </c:numCache>
+            </c:numRef>
           </c:bubbleSize>
           <c:bubble3D val="0"/>
           <c:extLst>
@@ -753,6 +1474,7 @@
         <c:axId val="392045280"/>
         <c:scaling>
           <c:orientation val="minMax"/>
+          <c:min val="0.0"/>
         </c:scaling>
         <c:delete val="0"/>
         <c:axPos val="b"/>
@@ -812,6 +1534,7 @@
         <c:axId val="392046992"/>
         <c:scaling>
           <c:orientation val="minMax"/>
+          <c:min val="0.0"/>
         </c:scaling>
         <c:delete val="0"/>
         <c:axPos val="l"/>
@@ -2086,7 +2809,7 @@
           <a:p>
             <a:fld id="{C1255C68-584F-174D-BB81-51BF91708794}" type="datetimeFigureOut">
               <a:rPr lang="en-US" smtClean="0"/>
-              <a:t>3/20/26</a:t>
+              <a:t>3/12/26</a:t>
             </a:fld>
             <a:endParaRPr lang="en-US"/>
           </a:p>
@@ -2263,7 +2986,7 @@
           <a:p>
             <a:fld id="{A1EDAAC4-819D-C544-9EA1-C73624CFD70B}" type="datetimeFigureOut">
               <a:rPr lang="en-US" smtClean="0"/>
-              <a:t>3/20/26</a:t>
+              <a:t>3/12/26</a:t>
             </a:fld>
             <a:endParaRPr lang="en-US"/>
           </a:p>
@@ -22660,6 +23383,7 @@
               <a:rPr lang="en-US" dirty="0"/>
               <a:t>Software Quality report on Reportgeneratordemo</a:t>
             </a:r>
+            <a:endParaRPr lang="en-US" dirty="0"/>
           </a:p>
         </p:txBody>
       </p:sp>
@@ -22749,7 +23473,7 @@
           <a:p>
             <a:r>
               <a:rPr lang="en-US" dirty="0" err="1"/>
-              <a:t>March 20, 2026</a:t>
+              <a:t>March 08, 2026</a:t>
             </a:r>
             <a:endParaRPr lang="en-US" dirty="0"/>
           </a:p>
@@ -32525,7 +33249,7 @@
         </p:nvGraphicFramePr>
         <p:xfrm>
           <a:off x="937766" y="1466791"/>
-          <a:ext cx="10316468" cy="4540320"/>
+          <a:ext cx="10316468" cy="17341920"/>
         </p:xfrm>
         <a:graphic>
           <a:graphicData uri="http://schemas.openxmlformats.org/drawingml/2006/table">
@@ -39573,7 +40297,7 @@
       </p:sp>
       <p:graphicFrame>
         <p:nvGraphicFramePr>
-          <p:cNvPr id="8" name="TECHNICAL_DEBT_SYSTEMS_CHART&#13;&#10;">
+          <p:cNvPr id="8" name="TECHNICAL_DEBT_SYSTEMS_CHART">
             <a:extLst>
               <a:ext uri="{FF2B5EF4-FFF2-40B4-BE49-F238E27FC236}">
                 <a16:creationId xmlns:a16="http://schemas.microsoft.com/office/drawing/2014/main" id="{220D7F51-72F0-DC6F-B733-E9F269FA92FE}"/>
@@ -39584,7 +40308,7 @@
           <p:nvPr>
             <p:extLst>
               <p:ext uri="{D42A27DB-BD31-4B8C-83A1-F6EECF244321}">
-                <p14:modId xmlns:p14="http://schemas.microsoft.com/office/powerpoint/2010/main" val="94991413"/>
+                <p14:modId xmlns:p14="http://schemas.microsoft.com/office/powerpoint/2010/main" val="1963346089"/>
               </p:ext>
             </p:extLst>
           </p:nvPr>
@@ -39998,7 +40722,7 @@
       </p:sp>
       <p:graphicFrame>
         <p:nvGraphicFramePr>
-          <p:cNvPr id="10" name="MODERNIZATION_SCATTER_PLOT_CHART&#13;&#10;">
+          <p:cNvPr id="10" name="MODERNIZATION_SCATTER_PLOT_CHART">
             <a:extLst>
               <a:ext uri="{FF2B5EF4-FFF2-40B4-BE49-F238E27FC236}">
                 <a16:creationId xmlns:a16="http://schemas.microsoft.com/office/drawing/2014/main" id="{FA04012A-8076-57D9-16E6-FD4DB5AABD99}"/>
@@ -40009,7 +40733,7 @@
           <p:nvPr>
             <p:extLst>
               <p:ext uri="{D42A27DB-BD31-4B8C-83A1-F6EECF244321}">
-                <p14:modId xmlns:p14="http://schemas.microsoft.com/office/powerpoint/2010/main" val="1380179552"/>
+                <p14:modId xmlns:p14="http://schemas.microsoft.com/office/powerpoint/2010/main" val="2991213908"/>
               </p:ext>
             </p:extLst>
           </p:nvPr>
@@ -41159,26 +41883,6 @@
 </file>
 
 <file path=customXml/item1.xml><?xml version="1.0" encoding="utf-8"?>
-<?mso-contentType ?>
-<FormTemplates xmlns="http://schemas.microsoft.com/sharepoint/v3/contenttype/forms">
-  <Display>DocumentLibraryForm</Display>
-  <Edit>DocumentLibraryForm</Edit>
-  <New>DocumentLibraryForm</New>
-</FormTemplates>
-</file>
-
-<file path=customXml/item2.xml><?xml version="1.0" encoding="utf-8"?>
-<p:properties xmlns:p="http://schemas.microsoft.com/office/2006/metadata/properties" xmlns:xsi="http://www.w3.org/2001/XMLSchema-instance" xmlns:pc="http://schemas.microsoft.com/office/infopath/2007/PartnerControls">
-  <documentManagement>
-    <lcf76f155ced4ddcb4097134ff3c332f xmlns="fa937df2-abe2-4d38-b5f4-c228acba3827">
-      <Terms xmlns="http://schemas.microsoft.com/office/infopath/2007/PartnerControls"/>
-    </lcf76f155ced4ddcb4097134ff3c332f>
-    <TaxCatchAll xmlns="bc8ba18a-4a58-4ad2-bfc0-6516af8e7dc2" xsi:nil="true"/>
-  </documentManagement>
-</p:properties>
-</file>
-
-<file path=customXml/item3.xml><?xml version="1.0" encoding="utf-8"?>
 <ct:contentTypeSchema xmlns:ct="http://schemas.microsoft.com/office/2006/metadata/contentType" xmlns:ma="http://schemas.microsoft.com/office/2006/metadata/properties/metaAttributes" ct:_="" ma:_="" ma:contentTypeName="Document" ma:contentTypeID="0x010100398B4EB28540854BB4092730D7F67224" ma:contentTypeVersion="13" ma:contentTypeDescription="Create a new document." ma:contentTypeScope="" ma:versionID="07d6997c7358ecc3b6f0d78039f1ac55">
   <xsd:schema xmlns:xsd="http://www.w3.org/2001/XMLSchema" xmlns:xs="http://www.w3.org/2001/XMLSchema" xmlns:p="http://schemas.microsoft.com/office/2006/metadata/properties" xmlns:ns2="fa937df2-abe2-4d38-b5f4-c228acba3827" xmlns:ns3="bc8ba18a-4a58-4ad2-bfc0-6516af8e7dc2" targetNamespace="http://schemas.microsoft.com/office/2006/metadata/properties" ma:root="true" ma:fieldsID="a7d20d2c9a349b6838acf4b79389f2fd" ns2:_="" ns3:_="">
     <xsd:import namespace="fa937df2-abe2-4d38-b5f4-c228acba3827"/>
@@ -41401,32 +42105,27 @@
 </ct:contentTypeSchema>
 </file>
 
-<file path=customXml/itemProps1.xml><?xml version="1.0" encoding="utf-8"?>
-<ds:datastoreItem xmlns:ds="http://schemas.openxmlformats.org/officeDocument/2006/customXml" ds:itemID="{570928F0-D7CA-4732-B7F3-1F945720D0AA}">
-  <ds:schemaRefs>
-    <ds:schemaRef ds:uri="http://schemas.microsoft.com/sharepoint/v3/contenttype/forms"/>
-  </ds:schemaRefs>
-</ds:datastoreItem>
+<file path=customXml/item2.xml><?xml version="1.0" encoding="utf-8"?>
+<?mso-contentType ?>
+<FormTemplates xmlns="http://schemas.microsoft.com/sharepoint/v3/contenttype/forms">
+  <Display>DocumentLibraryForm</Display>
+  <Edit>DocumentLibraryForm</Edit>
+  <New>DocumentLibraryForm</New>
+</FormTemplates>
 </file>
 
-<file path=customXml/itemProps2.xml><?xml version="1.0" encoding="utf-8"?>
-<ds:datastoreItem xmlns:ds="http://schemas.openxmlformats.org/officeDocument/2006/customXml" ds:itemID="{4B629362-CF15-4610-8FAC-A8E699942233}">
-  <ds:schemaRefs>
-    <ds:schemaRef ds:uri="http://schemas.microsoft.com/office/2006/documentManagement/types"/>
-    <ds:schemaRef ds:uri="http://purl.org/dc/elements/1.1/"/>
-    <ds:schemaRef ds:uri="bc8ba18a-4a58-4ad2-bfc0-6516af8e7dc2"/>
-    <ds:schemaRef ds:uri="http://purl.org/dc/terms/"/>
-    <ds:schemaRef ds:uri="http://www.w3.org/XML/1998/namespace"/>
-    <ds:schemaRef ds:uri="http://schemas.microsoft.com/office/2006/metadata/properties"/>
-    <ds:schemaRef ds:uri="http://schemas.microsoft.com/office/infopath/2007/PartnerControls"/>
-    <ds:schemaRef ds:uri="http://schemas.openxmlformats.org/package/2006/metadata/core-properties"/>
-    <ds:schemaRef ds:uri="fa937df2-abe2-4d38-b5f4-c228acba3827"/>
-    <ds:schemaRef ds:uri="http://purl.org/dc/dcmitype/"/>
-  </ds:schemaRefs>
-</ds:datastoreItem>
+<file path=customXml/item3.xml><?xml version="1.0" encoding="utf-8"?>
+<p:properties xmlns:p="http://schemas.microsoft.com/office/2006/metadata/properties" xmlns:xsi="http://www.w3.org/2001/XMLSchema-instance" xmlns:pc="http://schemas.microsoft.com/office/infopath/2007/PartnerControls">
+  <documentManagement>
+    <lcf76f155ced4ddcb4097134ff3c332f xmlns="fa937df2-abe2-4d38-b5f4-c228acba3827">
+      <Terms xmlns="http://schemas.microsoft.com/office/infopath/2007/PartnerControls"/>
+    </lcf76f155ced4ddcb4097134ff3c332f>
+    <TaxCatchAll xmlns="bc8ba18a-4a58-4ad2-bfc0-6516af8e7dc2" xsi:nil="true"/>
+  </documentManagement>
+</p:properties>
 </file>
 
-<file path=customXml/itemProps3.xml><?xml version="1.0" encoding="utf-8"?>
+<file path=customXml/itemProps1.xml><?xml version="1.0" encoding="utf-8"?>
 <ds:datastoreItem xmlns:ds="http://schemas.openxmlformats.org/officeDocument/2006/customXml" ds:itemID="{06E6923A-C221-4753-B75B-BA213EEB7564}">
   <ds:schemaRefs>
     <ds:schemaRef ds:uri="bc8ba18a-4a58-4ad2-bfc0-6516af8e7dc2"/>
@@ -41443,4 +42142,29 @@
     <ds:schemaRef ds:uri="http://www.w3.org/2001/XMLSchema"/>
   </ds:schemaRefs>
 </ds:datastoreItem>
+</file>
+
+<file path=customXml/itemProps2.xml><?xml version="1.0" encoding="utf-8"?>
+<ds:datastoreItem xmlns:ds="http://schemas.openxmlformats.org/officeDocument/2006/customXml" ds:itemID="{570928F0-D7CA-4732-B7F3-1F945720D0AA}">
+  <ds:schemaRefs>
+    <ds:schemaRef ds:uri="http://schemas.microsoft.com/sharepoint/v3/contenttype/forms"/>
+  </ds:schemaRefs>
+</ds:datastoreItem>
+</file>
+
+<file path=customXml/itemProps3.xml><?xml version="1.0" encoding="utf-8"?>
+<ds:datastoreItem xmlns:ds="http://schemas.openxmlformats.org/officeDocument/2006/customXml" ds:itemID="{4B629362-CF15-4610-8FAC-A8E699942233}">
+  <ds:schemaRefs>
+    <ds:schemaRef ds:uri="http://schemas.microsoft.com/office/2006/documentManagement/types"/>
+    <ds:schemaRef ds:uri="http://purl.org/dc/elements/1.1/"/>
+    <ds:schemaRef ds:uri="bc8ba18a-4a58-4ad2-bfc0-6516af8e7dc2"/>
+    <ds:schemaRef ds:uri="http://purl.org/dc/terms/"/>
+    <ds:schemaRef ds:uri="http://www.w3.org/XML/1998/namespace"/>
+    <ds:schemaRef ds:uri="http://schemas.microsoft.com/office/2006/metadata/properties"/>
+    <ds:schemaRef ds:uri="http://schemas.microsoft.com/office/infopath/2007/PartnerControls"/>
+    <ds:schemaRef ds:uri="http://schemas.openxmlformats.org/package/2006/metadata/core-properties"/>
+    <ds:schemaRef ds:uri="fa937df2-abe2-4d38-b5f4-c228acba3827"/>
+    <ds:schemaRef ds:uri="http://purl.org/dc/dcmitype/"/>
+  </ds:schemaRefs>
+</ds:datastoreItem>
 </file>
</xml_diff>